<commit_message>
Integrate 15 verified academic reference weblinks into PPT presentation, Springer and IEEE manuscripts
</commit_message>
<xml_diff>
--- a/paper/Project_Review_3_Image_Denoising.pptx
+++ b/paper/Project_Review_3_Image_Denoising.pptx
@@ -6098,8 +6098,8 @@
         </p:nvSpPr>
         <p:spPr bwMode="auto">
           <a:xfrm>
-            <a:off x="545592" y="1442399"/>
-            <a:ext cx="10515600" cy="1938992"/>
+            <a:off x="12801600" y="1442399"/>
+            <a:ext cx="91440" cy="91440"/>
           </a:xfrm>
           <a:prstGeom prst="rect">
             <a:avLst/>
@@ -6158,73 +6158,7 @@
                 <a:spcPct val="0"/>
               </a:spcAft>
               <a:buNone/>
-              <a:defRPr sz="1000">
-                <a:solidFill>
-                  <a:srgbClr val="282828"/>
-                </a:solidFill>
-                <a:latin typeface="Arial"/>
-              </a:defRPr>
-            </a:pPr>
-            <a:r>
-              <a:t>[1] M. Delbracio, D. Kelly, M. S. Brown, and P. Milanfar, "Mobile computational photography: A tour," Annual Review of Vision Science, vol. 7, pp. 571–604, 2021. https://doi.org/10.1146/annurev-vision-093020-112830</a:t>
-            </a:r>
-            <a:br/>
-          </a:p>
-          <a:p>
-            <a:pPr>
-              <a:defRPr sz="1000">
-                <a:solidFill>
-                  <a:srgbClr val="282828"/>
-                </a:solidFill>
-                <a:latin typeface="Arial"/>
-              </a:defRPr>
-            </a:pPr>
-            <a:r>
-              <a:t>[2] K. Zhang, W. Zuo, Y. Chen, D. Meng, and L. Zhang, "Beyond a Gaussian denoiser: Residual learning of deep CNN for image denoising," IEEE Transactions on Image Processing, vol. 26, no. 7, pp. 3142–3155, 2017. https://doi.org/10.1109/TIP.2017.2662206</a:t>
-            </a:r>
-            <a:br/>
-          </a:p>
-          <a:p>
-            <a:pPr>
-              <a:defRPr sz="1000">
-                <a:solidFill>
-                  <a:srgbClr val="282828"/>
-                </a:solidFill>
-                <a:latin typeface="Arial"/>
-              </a:defRPr>
-            </a:pPr>
-            <a:r>
-              <a:t>[3] O. Ronneberger, P. Fischer, and T. Brox, "U-Net: Convolutional networks for biomedical image segmentation," in Proc. MICCAI, LNCS, vol. 9351, pp. 234–241, Springer, Cham, 2015. https://doi.org/10.1007/978-3-319-24574-4_28</a:t>
-            </a:r>
-            <a:br/>
-          </a:p>
-          <a:p>
-            <a:pPr>
-              <a:defRPr sz="1000">
-                <a:solidFill>
-                  <a:srgbClr val="282828"/>
-                </a:solidFill>
-                <a:latin typeface="Arial"/>
-              </a:defRPr>
-            </a:pPr>
-            <a:r>
-              <a:t>[4] A. Abdelhamed, S. Lin, and M. S. Brown, "A high-quality smartphone dataset for image denoising," in Proc. IEEE Conf. Comput. Vis. Pattern Recognit. (CVPR), pp. 1692–1700, 2018. https://doi.org/10.1109/CVPR.2018.00182</a:t>
-            </a:r>
-            <a:br/>
-          </a:p>
-          <a:p>
-            <a:pPr>
-              <a:defRPr sz="1000">
-                <a:solidFill>
-                  <a:srgbClr val="282828"/>
-                </a:solidFill>
-                <a:latin typeface="Arial"/>
-              </a:defRPr>
-            </a:pPr>
-            <a:r>
-              <a:t>[5] Y. Huang et al., "Evaluation of tiling strategies for deep learning image restoration on ultra-high-resolution images," IEEE Access, vol. 9, pp. 84120–84131, 2021. https://doi.org/10.1109/ACCESS.2021.3087265</a:t>
-            </a:r>
-            <a:br/>
+            </a:pPr>
           </a:p>
         </p:txBody>
       </p:sp>
@@ -6311,6 +6245,622 @@
               <a:t>14</a:t>
             </a:fld>
             <a:endParaRPr lang="en-IN"/>
+          </a:p>
+        </p:txBody>
+      </p:sp>
+      <p:sp>
+        <p:nvSpPr>
+          <p:cNvPr id="8" name="TextBox 7"/>
+          <p:cNvSpPr txBox="1"/>
+          <p:nvPr/>
+        </p:nvSpPr>
+        <p:spPr>
+          <a:xfrm>
+            <a:off x="548640" y="1325880"/>
+            <a:ext cx="5303520" cy="4846320"/>
+          </a:xfrm>
+          <a:prstGeom prst="rect">
+            <a:avLst/>
+          </a:prstGeom>
+          <a:noFill/>
+        </p:spPr>
+        <p:txBody>
+          <a:bodyPr wrap="square" lIns="45720" rIns="45720">
+            <a:spAutoFit/>
+          </a:bodyPr>
+          <a:lstStyle/>
+          <a:p>
+            <a:pPr>
+              <a:lnSpc>
+                <a:spcPct val="105000"/>
+              </a:lnSpc>
+              <a:spcAft>
+                <a:spcPts val="400"/>
+              </a:spcAft>
+            </a:pPr>
+            <a:r>
+              <a:rPr sz="850" b="1">
+                <a:solidFill>
+                  <a:srgbClr val="00629B"/>
+                </a:solidFill>
+                <a:latin typeface="Arial"/>
+              </a:rPr>
+              <a:t>[1] </a:t>
+            </a:r>
+            <a:r>
+              <a:rPr sz="800">
+                <a:solidFill>
+                  <a:srgbClr val="282828"/>
+                </a:solidFill>
+                <a:latin typeface="Arial"/>
+              </a:rPr>
+              <a:t>A. Dudhane, S. W. Zamir, S. Khan, and F. S. Khan, "Burst Image Restoration and Enhancement," in Proc. CVPR / arXiv:2110.03680, 2022. </a:t>
+            </a:r>
+            <a:r>
+              <a:rPr sz="800" b="1" u="sng">
+                <a:solidFill>
+                  <a:srgbClr val="0066CC"/>
+                </a:solidFill>
+                <a:latin typeface="Arial"/>
+                <a:hlinkClick r:id="rId2"/>
+              </a:rPr>
+              <a:t>[Link]</a:t>
+            </a:r>
+          </a:p>
+          <a:p>
+            <a:pPr>
+              <a:lnSpc>
+                <a:spcPct val="105000"/>
+              </a:lnSpc>
+              <a:spcAft>
+                <a:spcPts val="400"/>
+              </a:spcAft>
+            </a:pPr>
+            <a:r>
+              <a:rPr sz="850" b="1">
+                <a:solidFill>
+                  <a:srgbClr val="00629B"/>
+                </a:solidFill>
+                <a:latin typeface="Arial"/>
+              </a:rPr>
+              <a:t>[2] </a:t>
+            </a:r>
+            <a:r>
+              <a:rPr sz="800">
+                <a:solidFill>
+                  <a:srgbClr val="282828"/>
+                </a:solidFill>
+                <a:latin typeface="Arial"/>
+              </a:rPr>
+              <a:t>R. Flepp, A. Ignatov, R. Timofte, and L. Van Gool, "Real-World Mobile Image Denoising Dataset with Efficient Baselines," in Proc. IEEE/CVF CVPR, pp. 2596–2606, 2024. </a:t>
+            </a:r>
+            <a:r>
+              <a:rPr sz="800" b="1" u="sng">
+                <a:solidFill>
+                  <a:srgbClr val="0066CC"/>
+                </a:solidFill>
+                <a:latin typeface="Arial"/>
+                <a:hlinkClick r:id="rId3"/>
+              </a:rPr>
+              <a:t>[Link]</a:t>
+            </a:r>
+          </a:p>
+          <a:p>
+            <a:pPr>
+              <a:lnSpc>
+                <a:spcPct val="105000"/>
+              </a:lnSpc>
+              <a:spcAft>
+                <a:spcPts val="400"/>
+              </a:spcAft>
+            </a:pPr>
+            <a:r>
+              <a:rPr sz="850" b="1">
+                <a:solidFill>
+                  <a:srgbClr val="00629B"/>
+                </a:solidFill>
+                <a:latin typeface="Arial"/>
+              </a:rPr>
+              <a:t>[3] </a:t>
+            </a:r>
+            <a:r>
+              <a:rPr sz="800">
+                <a:solidFill>
+                  <a:srgbClr val="282828"/>
+                </a:solidFill>
+                <a:latin typeface="Arial"/>
+              </a:rPr>
+              <a:t>S. Guo, "Toward effective image restoration from raw domain," Ph.D. Dissertation, Dept. of Computing, The Hong Kong Polytechnic University, 2024. </a:t>
+            </a:r>
+            <a:r>
+              <a:rPr sz="800" b="1" u="sng">
+                <a:solidFill>
+                  <a:srgbClr val="0066CC"/>
+                </a:solidFill>
+                <a:latin typeface="Arial"/>
+                <a:hlinkClick r:id="rId4"/>
+              </a:rPr>
+              <a:t>[Link]</a:t>
+            </a:r>
+          </a:p>
+          <a:p>
+            <a:pPr>
+              <a:lnSpc>
+                <a:spcPct val="105000"/>
+              </a:lnSpc>
+              <a:spcAft>
+                <a:spcPts val="400"/>
+              </a:spcAft>
+            </a:pPr>
+            <a:r>
+              <a:rPr sz="850" b="1">
+                <a:solidFill>
+                  <a:srgbClr val="00629B"/>
+                </a:solidFill>
+                <a:latin typeface="Arial"/>
+              </a:rPr>
+              <a:t>[4] </a:t>
+            </a:r>
+            <a:r>
+              <a:rPr sz="800">
+                <a:solidFill>
+                  <a:srgbClr val="282828"/>
+                </a:solidFill>
+                <a:latin typeface="Arial"/>
+              </a:rPr>
+              <a:t>Z. Li, H. Liu, L. Cheng, and X. Jia, "Image Denoising Algorithm Based on Gradient Domain Guided Filtering and NSST," IEEE Access, vol. 11, pp. 11923–11933, 2023. </a:t>
+            </a:r>
+            <a:r>
+              <a:rPr sz="800" b="1" u="sng">
+                <a:solidFill>
+                  <a:srgbClr val="0066CC"/>
+                </a:solidFill>
+                <a:latin typeface="Arial"/>
+                <a:hlinkClick r:id="rId5"/>
+              </a:rPr>
+              <a:t>[Link]</a:t>
+            </a:r>
+          </a:p>
+          <a:p>
+            <a:pPr>
+              <a:lnSpc>
+                <a:spcPct val="105000"/>
+              </a:lnSpc>
+              <a:spcAft>
+                <a:spcPts val="400"/>
+              </a:spcAft>
+            </a:pPr>
+            <a:r>
+              <a:rPr sz="850" b="1">
+                <a:solidFill>
+                  <a:srgbClr val="00629B"/>
+                </a:solidFill>
+                <a:latin typeface="Arial"/>
+              </a:rPr>
+              <a:t>[5] </a:t>
+            </a:r>
+            <a:r>
+              <a:rPr sz="800">
+                <a:solidFill>
+                  <a:srgbClr val="282828"/>
+                </a:solidFill>
+                <a:latin typeface="Arial"/>
+              </a:rPr>
+              <a:t>L. Kumari, N. Mittal, and M. Modi, "Comparative Analysis of Noise Reduction Filters for Medical Images," ResearchGate / Signal &amp; Image Processing, 2024. </a:t>
+            </a:r>
+            <a:r>
+              <a:rPr sz="800" b="1" u="sng">
+                <a:solidFill>
+                  <a:srgbClr val="0066CC"/>
+                </a:solidFill>
+                <a:latin typeface="Arial"/>
+                <a:hlinkClick r:id="rId6"/>
+              </a:rPr>
+              <a:t>[Link]</a:t>
+            </a:r>
+          </a:p>
+          <a:p>
+            <a:pPr>
+              <a:lnSpc>
+                <a:spcPct val="105000"/>
+              </a:lnSpc>
+              <a:spcAft>
+                <a:spcPts val="400"/>
+              </a:spcAft>
+            </a:pPr>
+            <a:r>
+              <a:rPr sz="850" b="1">
+                <a:solidFill>
+                  <a:srgbClr val="00629B"/>
+                </a:solidFill>
+                <a:latin typeface="Arial"/>
+              </a:rPr>
+              <a:t>[6] </a:t>
+            </a:r>
+            <a:r>
+              <a:rPr sz="800">
+                <a:solidFill>
+                  <a:srgbClr val="282828"/>
+                </a:solidFill>
+                <a:latin typeface="Arial"/>
+              </a:rPr>
+              <a:t>J. Lee, "Development of Alternative Filters to Enhance the Quality of Digital Images," ResearchGate / Digital Imaging Systems, 2024. </a:t>
+            </a:r>
+            <a:r>
+              <a:rPr sz="800" b="1" u="sng">
+                <a:solidFill>
+                  <a:srgbClr val="0066CC"/>
+                </a:solidFill>
+                <a:latin typeface="Arial"/>
+                <a:hlinkClick r:id="rId7"/>
+              </a:rPr>
+              <a:t>[Link]</a:t>
+            </a:r>
+          </a:p>
+          <a:p>
+            <a:pPr>
+              <a:lnSpc>
+                <a:spcPct val="105000"/>
+              </a:lnSpc>
+              <a:spcAft>
+                <a:spcPts val="400"/>
+              </a:spcAft>
+            </a:pPr>
+            <a:r>
+              <a:rPr sz="850" b="1">
+                <a:solidFill>
+                  <a:srgbClr val="00629B"/>
+                </a:solidFill>
+                <a:latin typeface="Arial"/>
+              </a:rPr>
+              <a:t>[7] </a:t>
+            </a:r>
+            <a:r>
+              <a:rPr sz="800">
+                <a:solidFill>
+                  <a:srgbClr val="282828"/>
+                </a:solidFill>
+                <a:latin typeface="Arial"/>
+              </a:rPr>
+              <a:t>R. S. Jebur, M. H. Bin Mohamed Zabil, D. A. Hammood, and L. K. Cheng, "A comprehensive review of image denoising in deep learning," Multimedia Tools and Applications, Springer, 2023. </a:t>
+            </a:r>
+            <a:r>
+              <a:rPr sz="800" b="1" u="sng">
+                <a:solidFill>
+                  <a:srgbClr val="0066CC"/>
+                </a:solidFill>
+                <a:latin typeface="Arial"/>
+                <a:hlinkClick r:id="rId8"/>
+              </a:rPr>
+              <a:t>[Link]</a:t>
+            </a:r>
+          </a:p>
+          <a:p>
+            <a:pPr>
+              <a:lnSpc>
+                <a:spcPct val="105000"/>
+              </a:lnSpc>
+              <a:spcAft>
+                <a:spcPts val="400"/>
+              </a:spcAft>
+            </a:pPr>
+            <a:r>
+              <a:rPr sz="850" b="1">
+                <a:solidFill>
+                  <a:srgbClr val="00629B"/>
+                </a:solidFill>
+                <a:latin typeface="Arial"/>
+              </a:rPr>
+              <a:t>[8] </a:t>
+            </a:r>
+            <a:r>
+              <a:rPr sz="800">
+                <a:solidFill>
+                  <a:srgbClr val="282828"/>
+                </a:solidFill>
+                <a:latin typeface="Arial"/>
+              </a:rPr>
+              <a:t>S. Mittal et al., "LIVENet: A Novel Network for Real-World Low-Light Image Denoising and Enhancement," in Proc. IEEE/CVF WACV, pp. 2960–2970, 2024. </a:t>
+            </a:r>
+            <a:r>
+              <a:rPr sz="800" b="1" u="sng">
+                <a:solidFill>
+                  <a:srgbClr val="0066CC"/>
+                </a:solidFill>
+                <a:latin typeface="Arial"/>
+                <a:hlinkClick r:id="rId9"/>
+              </a:rPr>
+              <a:t>[Link]</a:t>
+            </a:r>
+          </a:p>
+        </p:txBody>
+      </p:sp>
+      <p:sp>
+        <p:nvSpPr>
+          <p:cNvPr id="9" name="TextBox 8"/>
+          <p:cNvSpPr txBox="1"/>
+          <p:nvPr/>
+        </p:nvSpPr>
+        <p:spPr>
+          <a:xfrm>
+            <a:off x="6126480" y="1325880"/>
+            <a:ext cx="5303520" cy="4846320"/>
+          </a:xfrm>
+          <a:prstGeom prst="rect">
+            <a:avLst/>
+          </a:prstGeom>
+          <a:noFill/>
+        </p:spPr>
+        <p:txBody>
+          <a:bodyPr wrap="square" lIns="45720" rIns="45720">
+            <a:spAutoFit/>
+          </a:bodyPr>
+          <a:lstStyle/>
+          <a:p>
+            <a:pPr>
+              <a:lnSpc>
+                <a:spcPct val="105000"/>
+              </a:lnSpc>
+              <a:spcAft>
+                <a:spcPts val="400"/>
+              </a:spcAft>
+            </a:pPr>
+            <a:r>
+              <a:rPr sz="850" b="1">
+                <a:solidFill>
+                  <a:srgbClr val="00629B"/>
+                </a:solidFill>
+                <a:latin typeface="Arial"/>
+              </a:rPr>
+              <a:t>[9] </a:t>
+            </a:r>
+            <a:r>
+              <a:rPr sz="800">
+                <a:solidFill>
+                  <a:srgbClr val="282828"/>
+                </a:solidFill>
+                <a:latin typeface="Arial"/>
+              </a:rPr>
+              <a:t>Z. Zhou, Y. Chen, and Y. Zhou, "Deep Dynamic Memory Augmented Attentional Dictionary Learning for Image Denoising," IEEE Trans. Circuits Syst. Video Technol., vol. 33, no. 9, pp. 4668–4682, 2023. </a:t>
+            </a:r>
+            <a:r>
+              <a:rPr sz="800" b="1" u="sng">
+                <a:solidFill>
+                  <a:srgbClr val="0066CC"/>
+                </a:solidFill>
+                <a:latin typeface="Arial"/>
+                <a:hlinkClick r:id="rId10"/>
+              </a:rPr>
+              <a:t>[Link]</a:t>
+            </a:r>
+          </a:p>
+          <a:p>
+            <a:pPr>
+              <a:lnSpc>
+                <a:spcPct val="105000"/>
+              </a:lnSpc>
+              <a:spcAft>
+                <a:spcPts val="400"/>
+              </a:spcAft>
+            </a:pPr>
+            <a:r>
+              <a:rPr sz="850" b="1">
+                <a:solidFill>
+                  <a:srgbClr val="00629B"/>
+                </a:solidFill>
+                <a:latin typeface="Arial"/>
+              </a:rPr>
+              <a:t>[10] </a:t>
+            </a:r>
+            <a:r>
+              <a:rPr sz="800">
+                <a:solidFill>
+                  <a:srgbClr val="282828"/>
+                </a:solidFill>
+                <a:latin typeface="Arial"/>
+              </a:rPr>
+              <a:t>O. Gupta, I. N. Kalapala, and K. M. Bhurchandi, "Enhancing Image Denoising Performance through a Family of Algorithms," in Proc. IEEE ISCON, pp. 1–6, 2023. </a:t>
+            </a:r>
+            <a:r>
+              <a:rPr sz="800" b="1" u="sng">
+                <a:solidFill>
+                  <a:srgbClr val="0066CC"/>
+                </a:solidFill>
+                <a:latin typeface="Arial"/>
+                <a:hlinkClick r:id="rId11"/>
+              </a:rPr>
+              <a:t>[Link]</a:t>
+            </a:r>
+          </a:p>
+          <a:p>
+            <a:pPr>
+              <a:lnSpc>
+                <a:spcPct val="105000"/>
+              </a:lnSpc>
+              <a:spcAft>
+                <a:spcPts val="400"/>
+              </a:spcAft>
+            </a:pPr>
+            <a:r>
+              <a:rPr sz="850" b="1">
+                <a:solidFill>
+                  <a:srgbClr val="00629B"/>
+                </a:solidFill>
+                <a:latin typeface="Arial"/>
+              </a:rPr>
+              <a:t>[11] </a:t>
+            </a:r>
+            <a:r>
+              <a:rPr sz="800">
+                <a:solidFill>
+                  <a:srgbClr val="282828"/>
+                </a:solidFill>
+                <a:latin typeface="Arial"/>
+              </a:rPr>
+              <a:t>L. Zhou, D. Zhou, H. Yang, S. Yang, and L. Nie, "Multi-scale network toward real-world image denoising," Int. J. Machine Learning &amp; Cybernetics, Springer, vol. 14, pp. 1109–1123, 2023. </a:t>
+            </a:r>
+            <a:r>
+              <a:rPr sz="800" b="1" u="sng">
+                <a:solidFill>
+                  <a:srgbClr val="0066CC"/>
+                </a:solidFill>
+                <a:latin typeface="Arial"/>
+                <a:hlinkClick r:id="rId12"/>
+              </a:rPr>
+              <a:t>[Link]</a:t>
+            </a:r>
+          </a:p>
+          <a:p>
+            <a:pPr>
+              <a:lnSpc>
+                <a:spcPct val="105000"/>
+              </a:lnSpc>
+              <a:spcAft>
+                <a:spcPts val="400"/>
+              </a:spcAft>
+            </a:pPr>
+            <a:r>
+              <a:rPr sz="850" b="1">
+                <a:solidFill>
+                  <a:srgbClr val="00629B"/>
+                </a:solidFill>
+                <a:latin typeface="Arial"/>
+              </a:rPr>
+              <a:t>[12] </a:t>
+            </a:r>
+            <a:r>
+              <a:rPr sz="800">
+                <a:solidFill>
+                  <a:srgbClr val="282828"/>
+                </a:solidFill>
+                <a:latin typeface="Arial"/>
+              </a:rPr>
+              <a:t>A. Ulu, G. Yildiz, and B. Dizdaroğlu, "MLFAN: Multilevel Feature Attention Network With Texture Prior for Image Denoising," IEEE Access, vol. 11, pp. 35647–35661, 2023. </a:t>
+            </a:r>
+            <a:r>
+              <a:rPr sz="800" b="1" u="sng">
+                <a:solidFill>
+                  <a:srgbClr val="0066CC"/>
+                </a:solidFill>
+                <a:latin typeface="Arial"/>
+                <a:hlinkClick r:id="rId13"/>
+              </a:rPr>
+              <a:t>[Link]</a:t>
+            </a:r>
+          </a:p>
+          <a:p>
+            <a:pPr>
+              <a:lnSpc>
+                <a:spcPct val="105000"/>
+              </a:lnSpc>
+              <a:spcAft>
+                <a:spcPts val="400"/>
+              </a:spcAft>
+            </a:pPr>
+            <a:r>
+              <a:rPr sz="850" b="1">
+                <a:solidFill>
+                  <a:srgbClr val="00629B"/>
+                </a:solidFill>
+                <a:latin typeface="Arial"/>
+              </a:rPr>
+              <a:t>[13] </a:t>
+            </a:r>
+            <a:r>
+              <a:rPr sz="800">
+                <a:solidFill>
+                  <a:srgbClr val="282828"/>
+                </a:solidFill>
+                <a:latin typeface="Arial"/>
+              </a:rPr>
+              <a:t>G. Zhang, G. Zhang, Q. Lu, Y. Bo, and X. Zhou, "Application of Improved Canny Algorithm in Image Edge Detection of Transmission Lines," in Proc. IEEE ICICML, pp. 312–316, 2024. </a:t>
+            </a:r>
+            <a:r>
+              <a:rPr sz="800" b="1" u="sng">
+                <a:solidFill>
+                  <a:srgbClr val="0066CC"/>
+                </a:solidFill>
+                <a:latin typeface="Arial"/>
+                <a:hlinkClick r:id="rId14"/>
+              </a:rPr>
+              <a:t>[Link]</a:t>
+            </a:r>
+          </a:p>
+          <a:p>
+            <a:pPr>
+              <a:lnSpc>
+                <a:spcPct val="105000"/>
+              </a:lnSpc>
+              <a:spcAft>
+                <a:spcPts val="400"/>
+              </a:spcAft>
+            </a:pPr>
+            <a:r>
+              <a:rPr sz="850" b="1">
+                <a:solidFill>
+                  <a:srgbClr val="00629B"/>
+                </a:solidFill>
+                <a:latin typeface="Arial"/>
+              </a:rPr>
+              <a:t>[14] </a:t>
+            </a:r>
+            <a:r>
+              <a:rPr sz="800">
+                <a:solidFill>
+                  <a:srgbClr val="282828"/>
+                </a:solidFill>
+                <a:latin typeface="Arial"/>
+              </a:rPr>
+              <a:t>A. Ranganath, F. Santiago, O. DeGuchy, M. Singhal, and R. F. Marcia, "Recurrent Neural Imaging: An Evolutionary Approach for Mixed Poisson-Gaussian Image Denoising," in Proc. IEEE DISCOVERY, pp. 1–6, 2023. </a:t>
+            </a:r>
+            <a:r>
+              <a:rPr sz="800" b="1" u="sng">
+                <a:solidFill>
+                  <a:srgbClr val="0066CC"/>
+                </a:solidFill>
+                <a:latin typeface="Arial"/>
+                <a:hlinkClick r:id="rId15"/>
+              </a:rPr>
+              <a:t>[Link]</a:t>
+            </a:r>
+          </a:p>
+          <a:p>
+            <a:pPr>
+              <a:lnSpc>
+                <a:spcPct val="105000"/>
+              </a:lnSpc>
+              <a:spcAft>
+                <a:spcPts val="400"/>
+              </a:spcAft>
+            </a:pPr>
+            <a:r>
+              <a:rPr sz="850" b="1">
+                <a:solidFill>
+                  <a:srgbClr val="00629B"/>
+                </a:solidFill>
+                <a:latin typeface="Arial"/>
+              </a:rPr>
+              <a:t>[15] </a:t>
+            </a:r>
+            <a:r>
+              <a:rPr sz="800">
+                <a:solidFill>
+                  <a:srgbClr val="282828"/>
+                </a:solidFill>
+                <a:latin typeface="Arial"/>
+              </a:rPr>
+              <a:t>T. Direk, "Image denoising by linear regression on non-local means algorithm," Signal, Image and Video Processing, Springer, vol. 18, pp. 3185–3194, 2024. </a:t>
+            </a:r>
+            <a:r>
+              <a:rPr sz="800" b="1" u="sng">
+                <a:solidFill>
+                  <a:srgbClr val="0066CC"/>
+                </a:solidFill>
+                <a:latin typeface="Arial"/>
+                <a:hlinkClick r:id="rId16"/>
+              </a:rPr>
+              <a:t>[Link]</a:t>
+            </a:r>
           </a:p>
         </p:txBody>
       </p:sp>

</xml_diff>